<commit_message>
L14: replace tagline phrasing with explicit, factual headings throughout
</commit_message>
<xml_diff>
--- a/Week 7/L14_Making_It_Yours.pptx
+++ b/Week 7/L14_Making_It_Yours.pptx
@@ -3558,7 +3558,7 @@
                 </a:solidFill>
                 <a:latin typeface="Helvetica Neue"/>
               </a:rPr>
-              <a:t>Part 2: the layer that learns</a:t>
+              <a:t>Part 2: adapting a pretrained model to your own data</a:t>
             </a:r>
           </a:p>
         </p:txBody>
@@ -3593,7 +3593,7 @@
                 </a:solidFill>
                 <a:latin typeface="Helvetica Neue"/>
               </a:rPr>
-              <a:t>We have our own data. What would it actually buy us,</a:t>
+              <a:t>How much of your own labelled data does each method need,</a:t>
             </a:r>
           </a:p>
         </p:txBody>
@@ -3628,7 +3628,7 @@
                 </a:solidFill>
                 <a:latin typeface="Helvetica Neue"/>
               </a:rPr>
-              <a:t>and what would it cost?</a:t>
+              <a:t>and what does each one cost?</a:t>
             </a:r>
           </a:p>
         </p:txBody>
@@ -3657,13 +3657,13 @@
           <a:p>
             <a:pPr algn="l"/>
             <a:r>
-              <a:rPr sz="1600" b="0" i="1">
+              <a:rPr sz="1600" b="0" i="0">
                 <a:solidFill>
                   <a:srgbClr val="475569"/>
                 </a:solidFill>
                 <a:latin typeface="Helvetica Neue"/>
               </a:rPr>
-              <a:t>Seven rungs. Tonight we climb four of them and find out where to stop.</a:t>
+              <a:t>Rungs 1 and 2 were Lecture 13. Rung 3 is Week 8. Tonight covers rungs 4 to 7.</a:t>
             </a:r>
           </a:p>
         </p:txBody>
@@ -3751,7 +3751,7 @@
                 </a:solidFill>
                 <a:latin typeface="Helvetica Neue"/>
               </a:rPr>
-              <a:t>PRETRAINING TO FINE-TUNING</a:t>
+              <a:t>PRETRAINING AND FINE-TUNING</a:t>
             </a:r>
           </a:p>
         </p:txBody>
@@ -3780,13 +3780,13 @@
           <a:p>
             <a:pPr algn="l"/>
             <a:r>
-              <a:rPr sz="2800" b="1" i="0">
+              <a:rPr sz="2900" b="1" i="0">
                 <a:solidFill>
                   <a:srgbClr val="0F172A"/>
                 </a:solidFill>
                 <a:latin typeface="Helvetica Neue"/>
               </a:rPr>
-              <a:t>You are bolting a small piece on top.</a:t>
+              <a:t>What fine-tuning actually changes</a:t>
             </a:r>
           </a:p>
         </p:txBody>
@@ -3821,7 +3821,7 @@
                 </a:solidFill>
                 <a:latin typeface="Helvetica Neue"/>
               </a:rPr>
-              <a:t>Not retraining the model. What the words actually describe, and what the book says the default should be.</a:t>
+              <a:t>A small classifier is added on top of the pretrained encoder. The textbook default is to leave the encoder frozen, or to change only its last few layers.</a:t>
             </a:r>
           </a:p>
         </p:txBody>
@@ -4571,7 +4571,7 @@
                 </a:solidFill>
                 <a:latin typeface="Helvetica Neue"/>
               </a:rPr>
-              <a:t>Freeze the model. Learn one small rule.</a:t>
+              <a:t>Freeze the encoder, train only the head</a:t>
             </a:r>
           </a:p>
         </p:txBody>
@@ -4606,7 +4606,7 @@
                 </a:solidFill>
                 <a:latin typeface="Helvetica Neue"/>
               </a:rPr>
-              <a:t>The cheapest thing you can do with labelled data, and the one almost nobody tries first.</a:t>
+              <a:t>320 labelled tickets. 3,072 new parameters are trained and 22.7 million are left unchanged. Macro-F1 goes from 0.635 to 0.727.</a:t>
             </a:r>
           </a:p>
         </p:txBody>
@@ -5545,13 +5545,13 @@
           <a:p>
             <a:pPr algn="l"/>
             <a:r>
-              <a:rPr sz="2800" b="1" i="0">
+              <a:rPr sz="2900" b="1" i="0">
                 <a:solidFill>
                   <a:srgbClr val="0F172A"/>
                 </a:solidFill>
                 <a:latin typeface="Helvetica Neue"/>
               </a:rPr>
-              <a:t>Now spend twenty thousand times more.</a:t>
+              <a:t>Fine-tune all 66 million parameters</a:t>
             </a:r>
           </a:p>
         </p:txBody>
@@ -5586,7 +5586,7 @@
                 </a:solidFill>
                 <a:latin typeface="Helvetica Neue"/>
               </a:rPr>
-              <a:t>Same 320 tickets. Every weight in the model is free to move. Predict before you look.</a:t>
+              <a:t>The same 320 tickets, but every weight in the model may change. Write down your prediction before the result is shown.</a:t>
             </a:r>
           </a:p>
         </p:txBody>
@@ -6496,7 +6496,7 @@
                 </a:solidFill>
                 <a:latin typeface="Helvetica Neue"/>
               </a:rPr>
-              <a:t>HOW MANY LABELS?</a:t>
+              <a:t>LABELLING BUDGET</a:t>
             </a:r>
           </a:p>
         </p:txBody>
@@ -6525,13 +6525,13 @@
           <a:p>
             <a:pPr algn="l"/>
             <a:r>
-              <a:rPr sz="2900" b="1" i="0">
+              <a:rPr sz="2400" b="1" i="0">
                 <a:solidFill>
                   <a:srgbClr val="0F172A"/>
                 </a:solidFill>
                 <a:latin typeface="Helvetica Neue"/>
               </a:rPr>
-              <a:t>What your own data actually buys.</a:t>
+              <a:t>Accuracy against number of labelled tickets</a:t>
             </a:r>
           </a:p>
         </p:txBody>
@@ -6566,7 +6566,7 @@
                 </a:solidFill>
                 <a:latin typeface="Helvetica Neue"/>
               </a:rPr>
-              <a:t>Both rungs, every budget, measured on tickets neither of them ever trained on.</a:t>
+              <a:t>Both rungs at six budgets, measured on the 160 held-out hand-written tickets. Averaged over several runs per point.</a:t>
             </a:r>
           </a:p>
         </p:txBody>
@@ -7452,13 +7452,13 @@
           <a:p>
             <a:pPr algn="ctr"/>
             <a:r>
-              <a:rPr sz="1500" b="0" i="1">
+              <a:rPr sz="1500" b="0" i="0">
                 <a:solidFill>
                   <a:srgbClr val="475569"/>
                 </a:solidFill>
                 <a:latin typeface="Helvetica Neue"/>
               </a:rPr>
-              <a:t>The cheap rung is above the expensive one at every budget we can afford. And the curve bends: the next hundred labels is worth less than the last.</a:t>
+              <a:t>Rung 4 scores higher than rung 5 at every budget shown. Both curves flatten: going from 640 to 1,400 labels adds only 0.035 macro-F1.</a:t>
             </a:r>
           </a:p>
         </p:txBody>
@@ -7511,7 +7511,7 @@
                 </a:solidFill>
                 <a:latin typeface="Helvetica Neue"/>
               </a:rPr>
-              <a:t>THE GAME</a:t>
+              <a:t>IN-CLASS EXERCISE</a:t>
             </a:r>
           </a:p>
         </p:txBody>
@@ -7546,7 +7546,7 @@
                 </a:solidFill>
                 <a:latin typeface="Helvetica Neue"/>
               </a:rPr>
-              <a:t>You have money for 240 labels. Choose.</a:t>
+              <a:t>Choose which 240 of 1,400 tickets to label</a:t>
             </a:r>
           </a:p>
         </p:txBody>
@@ -7581,7 +7581,7 @@
                 </a:solidFill>
                 <a:latin typeface="Helvetica Neue"/>
               </a:rPr>
-              <a:t>Thirty minutes. Same budget for every team. The results are not close.</a:t>
+              <a:t>Every team gets the same budget. You may use the ticket text, the copilot's guess and its confidence, but not the true category.</a:t>
             </a:r>
           </a:p>
         </p:txBody>
@@ -7637,8 +7637,8 @@
         </p:blipFill>
         <p:spPr>
           <a:xfrm>
-            <a:off x="518007" y="2936926"/>
-            <a:ext cx="11155680" cy="2447186"/>
+            <a:off x="518007" y="2857985"/>
+            <a:ext cx="11155680" cy="2605069"/>
           </a:xfrm>
           <a:prstGeom prst="rect">
             <a:avLst/>
@@ -7888,7 +7888,7 @@
                 </a:solidFill>
                 <a:latin typeface="Helvetica Neue"/>
               </a:rPr>
-              <a:t>THE REVEAL</a:t>
+              <a:t>RESULTS</a:t>
             </a:r>
           </a:p>
         </p:txBody>
@@ -7923,7 +7923,7 @@
                 </a:solidFill>
                 <a:latin typeface="Helvetica Neue"/>
               </a:rPr>
-              <a:t>Same budget. Same model. Same code.</a:t>
+              <a:t>Six selection strategies at the same 240-label budget</a:t>
             </a:r>
           </a:p>
         </p:txBody>
@@ -7958,7 +7958,7 @@
                 </a:solidFill>
                 <a:latin typeface="Helvetica Neue"/>
               </a:rPr>
-              <a:t>Only the choice of WHICH 240 tickets to pay for changed.</a:t>
+              <a:t>Same model and same training code throughout. Only the choice of which tickets to label changed.</a:t>
             </a:r>
           </a:p>
         </p:txBody>
@@ -8052,7 +8052,7 @@
                 </a:solidFill>
                 <a:latin typeface="Helvetica Neue"/>
               </a:rPr>
-              <a:t>0.247 macro-F1 points between best and worst, for exactly the same money. Only one strategy beat random, and every rule that ranked by a score lost to it.</a:t>
+              <a:t>A range of 0.247 macro-F1 at identical cost. Only 'cover the space' scored above random plus one standard deviation. Every strategy that ranked tickets by a score scored below random.</a:t>
             </a:r>
           </a:p>
         </p:txBody>
@@ -8105,7 +8105,7 @@
                 </a:solidFill>
                 <a:latin typeface="Helvetica Neue"/>
               </a:rPr>
-              <a:t>WHY THE WINNER WON</a:t>
+              <a:t>RESULTS</a:t>
             </a:r>
           </a:p>
         </p:txBody>
@@ -8140,7 +8140,7 @@
                 </a:solidFill>
                 <a:latin typeface="Helvetica Neue"/>
               </a:rPr>
-              <a:t>Cover the space, not the score.</a:t>
+              <a:t>How each strategy spent its 240 labels</a:t>
             </a:r>
           </a:p>
         </p:txBody>
@@ -8175,7 +8175,7 @@
                 </a:solidFill>
                 <a:latin typeface="Helvetica Neue"/>
               </a:rPr>
-              <a:t>What each strategy actually bought. Flat bars at the top, lopsided ones at the bottom.</a:t>
+              <a:t>One bar per strategy, split by category, sorted by score. An even bar means the strategy bought some of every category.</a:t>
             </a:r>
           </a:p>
         </p:txBody>
@@ -8458,13 +8458,13 @@
           <a:p>
             <a:pPr algn="ctr"/>
             <a:r>
-              <a:rPr sz="1500" b="0" i="1">
+              <a:rPr sz="1500" b="0" i="0">
                 <a:solidFill>
                   <a:srgbClr val="475569"/>
                 </a:solidFill>
                 <a:latin typeface="Helvetica Neue"/>
               </a:rPr>
-              <a:t>Nobody could balance on the true labels: that is what we were paying for. Covering the vector space bought an even spread anyway, for free.</a:t>
+              <a:t>No strategy was allowed to balance on the true categories, since those are what the budget buys. Clustering the ticket vectors produced an even spread without using any label.</a:t>
             </a:r>
           </a:p>
         </p:txBody>
@@ -8517,7 +8517,7 @@
                 </a:solidFill>
                 <a:latin typeface="Helvetica Neue"/>
               </a:rPr>
-              <a:t>WHY THE WINNER WON</a:t>
+              <a:t>RESULTS</a:t>
             </a:r>
           </a:p>
         </p:txBody>
@@ -8552,7 +8552,7 @@
                 </a:solidFill>
                 <a:latin typeface="Helvetica Neue"/>
               </a:rPr>
-              <a:t>And it is not a coincidence.</a:t>
+              <a:t>Lopsided purchases scored lower</a:t>
             </a:r>
           </a:p>
         </p:txBody>
@@ -8587,7 +8587,7 @@
                 </a:solidFill>
                 <a:latin typeface="Helvetica Neue"/>
               </a:rPr>
-              <a:t>Every strategy from the reveal, plotted by how lopsided its purchase turned out.</a:t>
+              <a:t>Horizontal axis is the largest category count minus the smallest. Correlation with macro-F1 across all six strategies is -0.72.</a:t>
             </a:r>
           </a:p>
         </p:txBody>
@@ -8675,13 +8675,13 @@
           <a:p>
             <a:pPr algn="ctr"/>
             <a:r>
-              <a:rPr sz="1500" b="0" i="1">
+              <a:rPr sz="1500" b="0" i="0">
                 <a:solidFill>
                   <a:srgbClr val="475569"/>
                 </a:solidFill>
                 <a:latin typeface="Helvetica Neue"/>
               </a:rPr>
-              <a:t>Your selection rule quietly chooses your training distribution. Any rule that sorts by a score will skew it, and nobody notices until the model has a hole in it.</a:t>
+              <a:t>The rule used to select training data also determines its class distribution. Any rule that sorts by a score will skew that distribution, so check the mix before training.</a:t>
             </a:r>
           </a:p>
         </p:txBody>
@@ -8763,13 +8763,13 @@
           <a:p>
             <a:pPr algn="l"/>
             <a:r>
-              <a:rPr sz="2900" b="1" i="0">
+              <a:rPr sz="2550" b="1" i="0">
                 <a:solidFill>
                   <a:srgbClr val="0F172A"/>
                 </a:solidFill>
                 <a:latin typeface="Helvetica Neue"/>
               </a:rPr>
-              <a:t>Same architecture. Better recipe.</a:t>
+              <a:t>What RoBERTa changed, and what it did not</a:t>
             </a:r>
           </a:p>
         </p:txBody>
@@ -8804,7 +8804,7 @@
                 </a:solidFill>
                 <a:latin typeface="Helvetica Neue"/>
               </a:rPr>
-              <a:t>What actually changed between BERT and the model that beat it.</a:t>
+              <a:t>The architecture is unchanged. The training recipe changed: one objective dropped, larger batches, more text, longer training.</a:t>
             </a:r>
           </a:p>
         </p:txBody>
@@ -9519,7 +9519,7 @@
                 </a:solidFill>
                 <a:latin typeface="Helvetica Neue"/>
               </a:rPr>
-              <a:t>THE TOP OF THE LADDER</a:t>
+              <a:t>RUNGS 6 AND 7</a:t>
             </a:r>
           </a:p>
         </p:txBody>
@@ -9554,7 +9554,7 @@
                 </a:solidFill>
                 <a:latin typeface="Helvetica Neue"/>
               </a:rPr>
-              <a:t>Should Cobalt train its own model?</a:t>
+              <a:t>What the top two rungs cost</a:t>
             </a:r>
           </a:p>
         </p:txBody>
@@ -9589,7 +9589,7 @@
                 </a:solidFill>
                 <a:latin typeface="Helvetica Neue"/>
               </a:rPr>
-              <a:t>Somebody in the room is thinking it, so let us price it honestly.</a:t>
+              <a:t>Continued pretraining and training from scratch: what each requires, when each is worth doing, and why the answer for Cobalt is neither.</a:t>
             </a:r>
           </a:p>
         </p:txBody>
@@ -10248,8 +10248,8 @@
         </p:blipFill>
         <p:spPr>
           <a:xfrm>
-            <a:off x="518007" y="3102514"/>
-            <a:ext cx="11155680" cy="2116011"/>
+            <a:off x="518007" y="3015360"/>
+            <a:ext cx="11155680" cy="2290319"/>
           </a:xfrm>
           <a:prstGeom prst="rect">
             <a:avLst/>
@@ -10569,7 +10569,7 @@
                 </a:solidFill>
                 <a:latin typeface="Helvetica Neue"/>
               </a:rPr>
-              <a:t>The same map as last lecture. Greyed out is what we have already done; tonight is the bottom four.</a:t>
+              <a:t>The eight concepts for Week 7 and the five models we run. Greyed out was covered in Lecture 13. The four in green are covered tonight.</a:t>
             </a:r>
           </a:p>
         </p:txBody>
@@ -10681,7 +10681,7 @@
                 </a:solidFill>
                 <a:latin typeface="Helvetica Neue"/>
               </a:rPr>
-              <a:t>FULL CIRCLE</a:t>
+              <a:t>SUMMARY</a:t>
             </a:r>
           </a:p>
         </p:txBody>
@@ -10716,7 +10716,7 @@
                 </a:solidFill>
                 <a:latin typeface="Helvetica Neue"/>
               </a:rPr>
-              <a:t>Everything from both lectures, on one axis.</a:t>
+              <a:t>Every result from both lectures on one axis</a:t>
             </a:r>
           </a:p>
         </p:txBody>
@@ -10751,7 +10751,7 @@
                 </a:solidFill>
                 <a:latin typeface="Helvetica Neue"/>
               </a:rPr>
-              <a:t>Two evenings, one afternoon of labelling, no GPU bill.</a:t>
+              <a:t>Macro-F1 with no labels, with 240 labels chosen badly, 240 chosen at random, 240 chosen well, and with all 1,400 labelled.</a:t>
             </a:r>
           </a:p>
         </p:txBody>
@@ -10845,7 +10845,7 @@
                 </a:solidFill>
                 <a:latin typeface="Helvetica Neue"/>
               </a:rPr>
-              <a:t>Adapting a model is mostly a purchasing decision, not an engineering one.</a:t>
+              <a:t>240 labels chosen well reached 93% of the score obtained by labelling all 1,400 tickets.</a:t>
             </a:r>
           </a:p>
         </p:txBody>
@@ -10898,7 +10898,7 @@
                 </a:solidFill>
                 <a:latin typeface="Helvetica Neue"/>
               </a:rPr>
-              <a:t>BEFORE YOU GO</a:t>
+              <a:t>SUMMARY</a:t>
             </a:r>
           </a:p>
         </p:txBody>
@@ -10933,7 +10933,7 @@
                 </a:solidFill>
                 <a:latin typeface="Helvetica Neue"/>
               </a:rPr>
-              <a:t>Four things you can do at work on Monday.</a:t>
+              <a:t>Four things you can apply at work</a:t>
             </a:r>
           </a:p>
         </p:txBody>
@@ -11126,7 +11126,7 @@
                 </a:solidFill>
                 <a:latin typeface="Helvetica Neue"/>
               </a:rPr>
-              <a:t>Plot the curve before you commit</a:t>
+              <a:t>Plot the learning curve before committing to a labelling project</a:t>
             </a:r>
           </a:p>
         </p:txBody>
@@ -11161,7 +11161,7 @@
                 </a:solidFill>
                 <a:latin typeface="Helvetica Neue"/>
               </a:rPr>
-              <a:t>Label a few hundred, plot accuracy against budget, and find where it flattens. Teams routinely label for months past the point it changed a decision.</a:t>
+              <a:t>Label a few hundred examples, plot the score against the number of labels, and find where the curve flattens. That point, not a fixed target, is where labelling should stop.</a:t>
             </a:r>
           </a:p>
         </p:txBody>
@@ -11319,7 +11319,7 @@
                 </a:solidFill>
                 <a:latin typeface="Helvetica Neue"/>
               </a:rPr>
-              <a:t>Try the cheap rung first</a:t>
+              <a:t>Test the frozen-encoder option before approving a fine-tune</a:t>
             </a:r>
           </a:p>
         </p:txBody>
@@ -11354,7 +11354,7 @@
                 </a:solidFill>
                 <a:latin typeface="Helvetica Neue"/>
               </a:rPr>
-              <a:t>Frozen embeddings and a simple classifier. Make the expensive option prove it is better before you approve it.</a:t>
+              <a:t>Frozen embeddings with a simple classifier is faster and cheaper, and at these data sizes it scored higher. Require the more expensive option to demonstrate an improvement.</a:t>
             </a:r>
           </a:p>
         </p:txBody>
@@ -11512,7 +11512,7 @@
                 </a:solidFill>
                 <a:latin typeface="Helvetica Neue"/>
               </a:rPr>
-              <a:t>Check the class mix you bought</a:t>
+              <a:t>Check the class distribution of the training data you selected</a:t>
             </a:r>
           </a:p>
         </p:txBody>
@@ -11547,7 +11547,7 @@
                 </a:solidFill>
                 <a:latin typeface="Helvetica Neue"/>
               </a:rPr>
-              <a:t>Whatever rule chose your training data also chose your blind spots. Look for the zeros.</a:t>
+              <a:t>The selection rule determines the class mix, and the class mix determines where the model will fail. Inspect the counts per category before training.</a:t>
             </a:r>
           </a:p>
         </p:txBody>
@@ -11705,7 +11705,7 @@
                 </a:solidFill>
                 <a:latin typeface="Helvetica Neue"/>
               </a:rPr>
-              <a:t>Ask what rung they tried</a:t>
+              <a:t>Ask which adaptation methods have already been tried</a:t>
             </a:r>
           </a:p>
         </p:txBody>
@@ -11740,7 +11740,7 @@
                 </a:solidFill>
                 <a:latin typeface="Helvetica Neue"/>
               </a:rPr>
-              <a:t>When somebody proposes training a model from scratch, that is the question that ends the meeting early.</a:t>
+              <a:t>When training a model from scratch is proposed, establish first what rungs 1 through 5 scored. Also ask what random selection scored before accepting any clever selection method.</a:t>
             </a:r>
           </a:p>
         </p:txBody>
@@ -11793,7 +11793,7 @@
                 </a:solidFill>
                 <a:latin typeface="Helvetica Neue"/>
               </a:rPr>
-              <a:t>WHERE WE LEFT OFF</a:t>
+              <a:t>LECTURE 13 RECAP</a:t>
             </a:r>
           </a:p>
         </p:txBody>
@@ -11828,7 +11828,7 @@
                 </a:solidFill>
                 <a:latin typeface="Helvetica Neue"/>
               </a:rPr>
-              <a:t>Last lecture, with no training data at all.</a:t>
+              <a:t>What the copilot achieved with no training data</a:t>
             </a:r>
           </a:p>
         </p:txBody>
@@ -11863,7 +11863,7 @@
                 </a:solidFill>
                 <a:latin typeface="Helvetica Neue"/>
               </a:rPr>
-              <a:t>Same company, same inbox, same copilot. Tonight we ask what our own data would add.</a:t>
+              <a:t>Accuracy 64% on the first guess and 80% within its top two, on the same 160 tickets. Two categories were caught less than half the time.</a:t>
             </a:r>
           </a:p>
         </p:txBody>
@@ -11919,8 +11919,8 @@
         </p:blipFill>
         <p:spPr>
           <a:xfrm>
-            <a:off x="518007" y="3255053"/>
-            <a:ext cx="11155680" cy="1810933"/>
+            <a:off x="518007" y="3078932"/>
+            <a:ext cx="11155680" cy="2163174"/>
           </a:xfrm>
           <a:prstGeom prst="rect">
             <a:avLst/>
@@ -11975,7 +11975,7 @@
                 </a:solidFill>
                 <a:latin typeface="Helvetica Neue"/>
               </a:rPr>
-              <a:t>TONIGHT</a:t>
+              <a:t>THE ADAPTATION LADDER</a:t>
             </a:r>
           </a:p>
         </p:txBody>
@@ -12010,7 +12010,7 @@
                 </a:solidFill>
                 <a:latin typeface="Helvetica Neue"/>
               </a:rPr>
-              <a:t>There are seven ways to make a model yours.</a:t>
+              <a:t>Seven ways to adapt a model to your own data</a:t>
             </a:r>
           </a:p>
         </p:txBody>
@@ -12045,7 +12045,7 @@
                 </a:solidFill>
                 <a:latin typeface="Helvetica Neue"/>
               </a:rPr>
-              <a:t>Read it bottom to top. Cost climbs steeply. The payoff flattens early.</a:t>
+              <a:t>Ordered bottom to top by how much of your own data each one requires, with what each costs. Rungs 1 and 2 were Lecture 13; rung 3 is Week 8; rungs 4 to 7 are tonight.</a:t>
             </a:r>
           </a:p>
         </p:txBody>
@@ -12157,7 +12157,7 @@
                 </a:solidFill>
                 <a:latin typeface="Helvetica Neue"/>
               </a:rPr>
-              <a:t>HOW THE READING ABILITY WAS LEARNED</a:t>
+              <a:t>MASKED LANGUAGE MODELLING</a:t>
             </a:r>
           </a:p>
         </p:txBody>
@@ -12186,13 +12186,13 @@
           <a:p>
             <a:pPr algn="l"/>
             <a:r>
-              <a:rPr sz="2400" b="1" i="0">
+              <a:rPr sz="2900" b="1" i="0">
                 <a:solidFill>
                   <a:srgbClr val="0F172A"/>
                 </a:solidFill>
                 <a:latin typeface="Helvetica Neue"/>
               </a:rPr>
-              <a:t>Hide some of the words. Make it guess them.</a:t>
+              <a:t>How BERT was trained to read</a:t>
             </a:r>
           </a:p>
         </p:txBody>
@@ -12227,7 +12227,7 @@
                 </a:solidFill>
                 <a:latin typeface="Helvetica Neue"/>
               </a:rPr>
-              <a:t>The exercise BERT was trained on, and the two odd details that make it work.</a:t>
+              <a:t>15% of the words are chosen. Of those, 80% are replaced with a blank, 10% with a wrong word, and 10% are left unchanged. The right-hand panel explains why.</a:t>
             </a:r>
           </a:p>
         </p:txBody>
@@ -12942,7 +12942,7 @@
                 </a:solidFill>
                 <a:latin typeface="Helvetica Neue"/>
               </a:rPr>
-              <a:t>WHY ANY OF THIS WORKS</a:t>
+              <a:t>MASKED LANGUAGE MODELLING</a:t>
             </a:r>
           </a:p>
         </p:txBody>
@@ -12971,13 +12971,13 @@
           <a:p>
             <a:pPr algn="l"/>
             <a:r>
-              <a:rPr sz="2500" b="1" i="0">
+              <a:rPr sz="2900" b="1" i="0">
                 <a:solidFill>
                   <a:srgbClr val="0F172A"/>
                 </a:solidFill>
                 <a:latin typeface="Helvetica Neue"/>
               </a:rPr>
-              <a:t>Somebody already paid to teach it English.</a:t>
+              <a:t>The fill-in-the-blank task, run live</a:t>
             </a:r>
           </a:p>
         </p:txBody>
@@ -13012,7 +13012,7 @@
                 </a:solidFill>
                 <a:latin typeface="Helvetica Neue"/>
               </a:rPr>
-              <a:t>This is the exercise they used. It needs no labelled data, which is why it could be done at scale.</a:t>
+              <a:t>bert-base-uncased predicting a hidden word from the words around it. No labelled data is needed for this, which is why it could be run on very large amounts of text.</a:t>
             </a:r>
           </a:p>
         </p:txBody>
@@ -13922,7 +13922,7 @@
                 </a:solidFill>
                 <a:latin typeface="Helvetica Neue"/>
               </a:rPr>
-              <a:t>WHY ANY OF THIS WORKS</a:t>
+              <a:t>MASKED LANGUAGE MODELLING</a:t>
             </a:r>
           </a:p>
         </p:txBody>
@@ -13951,13 +13951,13 @@
           <a:p>
             <a:pPr algn="l"/>
             <a:r>
-              <a:rPr sz="2500" b="1" i="0">
+              <a:rPr sz="2900" b="1" i="0">
                 <a:solidFill>
                   <a:srgbClr val="0F172A"/>
                 </a:solidFill>
                 <a:latin typeface="Helvetica Neue"/>
               </a:rPr>
-              <a:t>And here is exactly what it does not know.</a:t>
+              <a:t>The same task on product vocabulary</a:t>
             </a:r>
           </a:p>
         </p:txBody>
@@ -13992,7 +13992,7 @@
                 </a:solidFill>
                 <a:latin typeface="Helvetica Neue"/>
               </a:rPr>
-              <a:t>The same fill-in-the-blank game, asked about our world instead of the general one.</a:t>
+              <a:t>The same model and the same task, asked to fill a blank whose answer is a vendor name it rarely encountered during pretraining.</a:t>
             </a:r>
           </a:p>
         </p:txBody>
@@ -14902,7 +14902,7 @@
                 </a:solidFill>
                 <a:latin typeface="Helvetica Neue"/>
               </a:rPr>
-              <a:t>TWO SHAPES OF MODEL</a:t>
+              <a:t>ENCODER AND DECODER MODELS</a:t>
             </a:r>
           </a:p>
         </p:txBody>
@@ -14937,7 +14937,7 @@
                 </a:solidFill>
                 <a:latin typeface="Helvetica Neue"/>
               </a:rPr>
-              <a:t>The whole difference is one blacked-out triangle.</a:t>
+              <a:t>Which words each model is allowed to look at</a:t>
             </a:r>
           </a:p>
         </p:txBody>
@@ -14972,7 +14972,7 @@
                 </a:solidFill>
                 <a:latin typeface="Helvetica Neue"/>
               </a:rPr>
-              <a:t>Every row is a word doing the looking. Every column is a word it is allowed to look at.</a:t>
+              <a:t>Each row is a word doing the looking; each column is a word being looked at. Green is permitted, black is blocked.</a:t>
             </a:r>
           </a:p>
         </p:txBody>
@@ -15084,7 +15084,7 @@
                 </a:solidFill>
                 <a:latin typeface="Helvetica Neue"/>
               </a:rPr>
-              <a:t>TWO SHAPES OF MODEL</a:t>
+              <a:t>ENCODER AND DECODER MODELS</a:t>
             </a:r>
           </a:p>
         </p:txBody>
@@ -15119,7 +15119,7 @@
                 </a:solidFill>
                 <a:latin typeface="Helvetica Neue"/>
               </a:rPr>
-              <a:t>Why BERT reads and GPT writes.</a:t>
+              <a:t>What each of the two is used for</a:t>
             </a:r>
           </a:p>
         </p:txBody>
@@ -15154,7 +15154,7 @@
                 </a:solidFill>
                 <a:latin typeface="Helvetica Neue"/>
               </a:rPr>
-              <a:t>Same transformer block from last lecture. One difference: may a word look to its right?</a:t>
+              <a:t>Both use the transformer block from Lecture 13. The only difference is whether a word may look at the words to its right.</a:t>
             </a:r>
           </a:p>
         </p:txBody>

</xml_diff>

<commit_message>
L14 exercise: project teams, 5-seed official scoring, winner criteria
</commit_message>
<xml_diff>
--- a/Week 7/L14_Making_It_Yours.pptx
+++ b/Week 7/L14_Making_It_Yours.pptx
@@ -7581,7 +7581,7 @@
                 </a:solidFill>
                 <a:latin typeface="Helvetica Neue"/>
               </a:rPr>
-              <a:t>Every team gets the same budget. You may use the ticket text, the copilot's guess and its confidence, but not the true category.</a:t>
+              <a:t>Final project teams. Same budget for every team. Scored on held-out tickets, averaged over 5 seeds.</a:t>
             </a:r>
           </a:p>
         </p:txBody>
@@ -7637,8 +7637,8 @@
         </p:blipFill>
         <p:spPr>
           <a:xfrm>
-            <a:off x="518007" y="2857985"/>
-            <a:ext cx="11155680" cy="2605069"/>
+            <a:off x="518007" y="2760703"/>
+            <a:ext cx="11155680" cy="2799632"/>
           </a:xfrm>
           <a:prstGeom prst="rect">
             <a:avLst/>

</xml_diff>

<commit_message>
L14: add discussion slide on Meta's Applied AI annotation unit
</commit_message>
<xml_diff>
--- a/Week 7/L14_Making_It_Yours.pptx
+++ b/Week 7/L14_Making_It_Yours.pptx
@@ -26,6 +26,7 @@
     <p:sldId id="274" r:id="rId25"/>
     <p:sldId id="275" r:id="rId26"/>
     <p:sldId id="276" r:id="rId27"/>
+    <p:sldId id="277" r:id="rId28"/>
   </p:sldIdLst>
   <p:sldSz cx="12191695" cy="6858000" type="screen4x3"/>
   <p:notesSz cx="6858000" cy="9144000"/>
@@ -11745,6 +11746,188 @@
           </a:p>
         </p:txBody>
       </p:sp>
+    </p:spTree>
+  </p:cSld>
+  <p:clrMapOvr>
+    <a:masterClrMapping/>
+  </p:clrMapOvr>
+</p:sld>
+</file>
+
+<file path=ppt/slides/slide22.xml><?xml version="1.0" encoding="utf-8"?>
+<p:sld xmlns:a="http://schemas.openxmlformats.org/drawingml/2006/main" xmlns:p="http://schemas.openxmlformats.org/presentationml/2006/main" xmlns:r="http://schemas.openxmlformats.org/officeDocument/2006/relationships">
+  <p:cSld>
+    <p:spTree>
+      <p:nvGrpSpPr>
+        <p:cNvPr id="1" name=""/>
+        <p:cNvGrpSpPr/>
+        <p:nvPr/>
+      </p:nvGrpSpPr>
+      <p:grpSpPr/>
+      <p:sp>
+        <p:nvSpPr>
+          <p:cNvPr id="2" name="TextBox 1"/>
+          <p:cNvSpPr txBox="1"/>
+          <p:nvPr/>
+        </p:nvSpPr>
+        <p:spPr>
+          <a:xfrm>
+            <a:off x="640080" y="457200"/>
+            <a:ext cx="6766560" cy="274320"/>
+          </a:xfrm>
+          <a:prstGeom prst="rect">
+            <a:avLst/>
+          </a:prstGeom>
+          <a:noFill/>
+        </p:spPr>
+        <p:txBody>
+          <a:bodyPr wrap="square" lIns="0" rIns="0" tIns="0" bIns="0">
+            <a:spAutoFit/>
+          </a:bodyPr>
+          <a:lstStyle/>
+          <a:p>
+            <a:pPr algn="l"/>
+            <a:r>
+              <a:rPr sz="1250" b="1" i="0" spc="220">
+                <a:solidFill>
+                  <a:srgbClr val="E11D48"/>
+                </a:solidFill>
+                <a:latin typeface="Helvetica Neue"/>
+              </a:rPr>
+              <a:t>DISCUSSION</a:t>
+            </a:r>
+          </a:p>
+        </p:txBody>
+      </p:sp>
+      <p:sp>
+        <p:nvSpPr>
+          <p:cNvPr id="3" name="TextBox 2"/>
+          <p:cNvSpPr txBox="1"/>
+          <p:nvPr/>
+        </p:nvSpPr>
+        <p:spPr>
+          <a:xfrm>
+            <a:off x="640080" y="758952"/>
+            <a:ext cx="10972800" cy="704088"/>
+          </a:xfrm>
+          <a:prstGeom prst="rect">
+            <a:avLst/>
+          </a:prstGeom>
+          <a:noFill/>
+        </p:spPr>
+        <p:txBody>
+          <a:bodyPr wrap="square" lIns="0" rIns="0" tIns="0" bIns="0">
+            <a:spAutoFit/>
+          </a:bodyPr>
+          <a:lstStyle/>
+          <a:p>
+            <a:pPr algn="l"/>
+            <a:r>
+              <a:rPr sz="2900" b="1" i="0">
+                <a:solidFill>
+                  <a:srgbClr val="0F172A"/>
+                </a:solidFill>
+                <a:latin typeface="Helvetica Neue"/>
+              </a:rPr>
+              <a:t>Meta moved 6,500 engineers into data annotation</a:t>
+            </a:r>
+          </a:p>
+        </p:txBody>
+      </p:sp>
+      <p:sp>
+        <p:nvSpPr>
+          <p:cNvPr id="4" name="TextBox 3"/>
+          <p:cNvSpPr txBox="1"/>
+          <p:nvPr/>
+        </p:nvSpPr>
+        <p:spPr>
+          <a:xfrm>
+            <a:off x="640080" y="1417320"/>
+            <a:ext cx="10424160" cy="457200"/>
+          </a:xfrm>
+          <a:prstGeom prst="rect">
+            <a:avLst/>
+          </a:prstGeom>
+          <a:noFill/>
+        </p:spPr>
+        <p:txBody>
+          <a:bodyPr wrap="square" lIns="0" rIns="0" tIns="0" bIns="0">
+            <a:spAutoFit/>
+          </a:bodyPr>
+          <a:lstStyle/>
+          <a:p>
+            <a:pPr algn="l"/>
+            <a:r>
+              <a:rPr sz="1500" b="0" i="0">
+                <a:solidFill>
+                  <a:srgbClr val="475569"/>
+                </a:solidFill>
+                <a:latin typeface="Helvetica Neue"/>
+              </a:rPr>
+              <a:t>March to June 2026. The same bottleneck we priced tonight, at a scale where it reorganised a company.</a:t>
+            </a:r>
+          </a:p>
+        </p:txBody>
+      </p:sp>
+      <p:sp>
+        <p:nvSpPr>
+          <p:cNvPr id="5" name="TextBox 4"/>
+          <p:cNvSpPr txBox="1"/>
+          <p:nvPr/>
+        </p:nvSpPr>
+        <p:spPr>
+          <a:xfrm>
+            <a:off x="640080" y="6492240"/>
+            <a:ext cx="8229600" cy="274320"/>
+          </a:xfrm>
+          <a:prstGeom prst="rect">
+            <a:avLst/>
+          </a:prstGeom>
+          <a:noFill/>
+        </p:spPr>
+        <p:txBody>
+          <a:bodyPr wrap="square" lIns="0" rIns="0" tIns="0" bIns="0">
+            <a:spAutoFit/>
+          </a:bodyPr>
+          <a:lstStyle/>
+          <a:p>
+            <a:pPr algn="l"/>
+            <a:r>
+              <a:rPr sz="900" b="0" i="0">
+                <a:solidFill>
+                  <a:srgbClr val="BCC1CC"/>
+                </a:solidFill>
+                <a:latin typeface="Helvetica Neue"/>
+              </a:rPr>
+              <a:t>ISBA 2411 · Natural Language Processing &amp; AI · Summer 2026</a:t>
+            </a:r>
+          </a:p>
+        </p:txBody>
+      </p:sp>
+      <p:pic>
+        <p:nvPicPr>
+          <p:cNvPr id="6" name="Picture 5" descr="d_metaincident.png"/>
+          <p:cNvPicPr>
+            <a:picLocks noChangeAspect="1"/>
+          </p:cNvPicPr>
+          <p:nvPr/>
+        </p:nvPicPr>
+        <p:blipFill>
+          <a:blip r:embed="rId2"/>
+          <a:stretch>
+            <a:fillRect/>
+          </a:stretch>
+        </p:blipFill>
+        <p:spPr>
+          <a:xfrm>
+            <a:off x="335127" y="2612966"/>
+            <a:ext cx="11521440" cy="3186547"/>
+          </a:xfrm>
+          <a:prstGeom prst="rect">
+            <a:avLst/>
+          </a:prstGeom>
+        </p:spPr>
+      </p:pic>
     </p:spTree>
   </p:cSld>
   <p:clrMapOvr>

</xml_diff>